<commit_message>
Add publication assets and manuscript files
</commit_message>
<xml_diff>
--- a/煤科投稿/论文图片包/画图.pptx
+++ b/煤科投稿/论文图片包/画图.pptx
@@ -5,11 +5,12 @@
     <p:sldMasterId id="2147483660" r:id="rId1"/>
   </p:sldMasterIdLst>
   <p:notesMasterIdLst>
-    <p:notesMasterId r:id="rId4"/>
+    <p:notesMasterId r:id="rId5"/>
   </p:notesMasterIdLst>
   <p:sldIdLst>
     <p:sldId id="256" r:id="rId2"/>
     <p:sldId id="257" r:id="rId3"/>
+    <p:sldId id="258" r:id="rId4"/>
   </p:sldIdLst>
   <p:sldSz cx="6858000" cy="9906000" type="A4"/>
   <p:notesSz cx="6858000" cy="9144000"/>
@@ -108,6 +109,11 @@
       </a:defRPr>
     </a:lvl9pPr>
   </p:defaultTextStyle>
+  <p:extLst>
+    <p:ext uri="{EFAFB233-063F-42B5-8137-9DF3F51BA10A}">
+      <p15:sldGuideLst xmlns:p15="http://schemas.microsoft.com/office/powerpoint/2012/main"/>
+    </p:ext>
+  </p:extLst>
 </p:presentation>
 </file>
 
@@ -193,7 +199,7 @@
           <a:p>
             <a:fld id="{1C314F14-73D4-4D62-B57B-42E5203CBFCD}" type="datetimeFigureOut">
               <a:rPr lang="zh-CN" altLang="en-US" smtClean="0"/>
-              <a:t>2026/5/12</a:t>
+              <a:t>2026/5/15</a:t>
             </a:fld>
             <a:endParaRPr lang="zh-CN" altLang="en-US"/>
           </a:p>
@@ -680,7 +686,7 @@
           <a:p>
             <a:fld id="{7B6ED52D-95DF-48E9-888C-E126D2552AD7}" type="datetimeFigureOut">
               <a:rPr lang="zh-CN" altLang="en-US" smtClean="0"/>
-              <a:t>2026/5/12</a:t>
+              <a:t>2026/5/15</a:t>
             </a:fld>
             <a:endParaRPr lang="zh-CN" altLang="en-US"/>
           </a:p>
@@ -850,7 +856,7 @@
           <a:p>
             <a:fld id="{7B6ED52D-95DF-48E9-888C-E126D2552AD7}" type="datetimeFigureOut">
               <a:rPr lang="zh-CN" altLang="en-US" smtClean="0"/>
-              <a:t>2026/5/12</a:t>
+              <a:t>2026/5/15</a:t>
             </a:fld>
             <a:endParaRPr lang="zh-CN" altLang="en-US"/>
           </a:p>
@@ -1030,7 +1036,7 @@
           <a:p>
             <a:fld id="{7B6ED52D-95DF-48E9-888C-E126D2552AD7}" type="datetimeFigureOut">
               <a:rPr lang="zh-CN" altLang="en-US" smtClean="0"/>
-              <a:t>2026/5/12</a:t>
+              <a:t>2026/5/15</a:t>
             </a:fld>
             <a:endParaRPr lang="zh-CN" altLang="en-US"/>
           </a:p>
@@ -1200,7 +1206,7 @@
           <a:p>
             <a:fld id="{7B6ED52D-95DF-48E9-888C-E126D2552AD7}" type="datetimeFigureOut">
               <a:rPr lang="zh-CN" altLang="en-US" smtClean="0"/>
-              <a:t>2026/5/12</a:t>
+              <a:t>2026/5/15</a:t>
             </a:fld>
             <a:endParaRPr lang="zh-CN" altLang="en-US"/>
           </a:p>
@@ -1446,7 +1452,7 @@
           <a:p>
             <a:fld id="{7B6ED52D-95DF-48E9-888C-E126D2552AD7}" type="datetimeFigureOut">
               <a:rPr lang="zh-CN" altLang="en-US" smtClean="0"/>
-              <a:t>2026/5/12</a:t>
+              <a:t>2026/5/15</a:t>
             </a:fld>
             <a:endParaRPr lang="zh-CN" altLang="en-US"/>
           </a:p>
@@ -1678,7 +1684,7 @@
           <a:p>
             <a:fld id="{7B6ED52D-95DF-48E9-888C-E126D2552AD7}" type="datetimeFigureOut">
               <a:rPr lang="zh-CN" altLang="en-US" smtClean="0"/>
-              <a:t>2026/5/12</a:t>
+              <a:t>2026/5/15</a:t>
             </a:fld>
             <a:endParaRPr lang="zh-CN" altLang="en-US"/>
           </a:p>
@@ -2045,7 +2051,7 @@
           <a:p>
             <a:fld id="{7B6ED52D-95DF-48E9-888C-E126D2552AD7}" type="datetimeFigureOut">
               <a:rPr lang="zh-CN" altLang="en-US" smtClean="0"/>
-              <a:t>2026/5/12</a:t>
+              <a:t>2026/5/15</a:t>
             </a:fld>
             <a:endParaRPr lang="zh-CN" altLang="en-US"/>
           </a:p>
@@ -2163,7 +2169,7 @@
           <a:p>
             <a:fld id="{7B6ED52D-95DF-48E9-888C-E126D2552AD7}" type="datetimeFigureOut">
               <a:rPr lang="zh-CN" altLang="en-US" smtClean="0"/>
-              <a:t>2026/5/12</a:t>
+              <a:t>2026/5/15</a:t>
             </a:fld>
             <a:endParaRPr lang="zh-CN" altLang="en-US"/>
           </a:p>
@@ -2258,7 +2264,7 @@
           <a:p>
             <a:fld id="{7B6ED52D-95DF-48E9-888C-E126D2552AD7}" type="datetimeFigureOut">
               <a:rPr lang="zh-CN" altLang="en-US" smtClean="0"/>
-              <a:t>2026/5/12</a:t>
+              <a:t>2026/5/15</a:t>
             </a:fld>
             <a:endParaRPr lang="zh-CN" altLang="en-US"/>
           </a:p>
@@ -2535,7 +2541,7 @@
           <a:p>
             <a:fld id="{7B6ED52D-95DF-48E9-888C-E126D2552AD7}" type="datetimeFigureOut">
               <a:rPr lang="zh-CN" altLang="en-US" smtClean="0"/>
-              <a:t>2026/5/12</a:t>
+              <a:t>2026/5/15</a:t>
             </a:fld>
             <a:endParaRPr lang="zh-CN" altLang="en-US"/>
           </a:p>
@@ -2792,7 +2798,7 @@
           <a:p>
             <a:fld id="{7B6ED52D-95DF-48E9-888C-E126D2552AD7}" type="datetimeFigureOut">
               <a:rPr lang="zh-CN" altLang="en-US" smtClean="0"/>
-              <a:t>2026/5/12</a:t>
+              <a:t>2026/5/15</a:t>
             </a:fld>
             <a:endParaRPr lang="zh-CN" altLang="en-US"/>
           </a:p>
@@ -3005,7 +3011,7 @@
           <a:p>
             <a:fld id="{7B6ED52D-95DF-48E9-888C-E126D2552AD7}" type="datetimeFigureOut">
               <a:rPr lang="zh-CN" altLang="en-US" smtClean="0"/>
-              <a:t>2026/5/12</a:t>
+              <a:t>2026/5/15</a:t>
             </a:fld>
             <a:endParaRPr lang="zh-CN" altLang="en-US"/>
           </a:p>
@@ -4327,6 +4333,572 @@
 </p:sld>
 </file>
 
+<file path=ppt/slides/slide3.xml><?xml version="1.0" encoding="utf-8"?>
+<p:sld xmlns:a="http://schemas.openxmlformats.org/drawingml/2006/main" xmlns:r="http://schemas.openxmlformats.org/officeDocument/2006/relationships" xmlns:p="http://schemas.openxmlformats.org/presentationml/2006/main">
+  <p:cSld>
+    <p:spTree>
+      <p:nvGrpSpPr>
+        <p:cNvPr id="1" name=""/>
+        <p:cNvGrpSpPr/>
+        <p:nvPr/>
+      </p:nvGrpSpPr>
+      <p:grpSpPr>
+        <a:xfrm>
+          <a:off x="0" y="0"/>
+          <a:ext cx="0" cy="0"/>
+          <a:chOff x="0" y="0"/>
+          <a:chExt cx="0" cy="0"/>
+        </a:xfrm>
+      </p:grpSpPr>
+      <p:grpSp>
+        <p:nvGrpSpPr>
+          <p:cNvPr id="22" name="组合 21">
+            <a:extLst>
+              <a:ext uri="{FF2B5EF4-FFF2-40B4-BE49-F238E27FC236}">
+                <a16:creationId xmlns:a16="http://schemas.microsoft.com/office/drawing/2014/main" id="{D0E9DEFD-D454-72BB-ECD8-7638BD9248E4}"/>
+              </a:ext>
+            </a:extLst>
+          </p:cNvPr>
+          <p:cNvGrpSpPr/>
+          <p:nvPr/>
+        </p:nvGrpSpPr>
+        <p:grpSpPr>
+          <a:xfrm>
+            <a:off x="115253" y="3053940"/>
+            <a:ext cx="6742747" cy="4028952"/>
+            <a:chOff x="115253" y="3053940"/>
+            <a:chExt cx="6742747" cy="4028952"/>
+          </a:xfrm>
+        </p:grpSpPr>
+        <p:pic>
+          <p:nvPicPr>
+            <p:cNvPr id="5" name="图片 4">
+              <a:extLst>
+                <a:ext uri="{FF2B5EF4-FFF2-40B4-BE49-F238E27FC236}">
+                  <a16:creationId xmlns:a16="http://schemas.microsoft.com/office/drawing/2014/main" id="{8C4970BE-12B2-78C9-2021-0BA2CCC4F0B4}"/>
+                </a:ext>
+              </a:extLst>
+            </p:cNvPr>
+            <p:cNvPicPr>
+              <a:picLocks noChangeAspect="1"/>
+            </p:cNvPicPr>
+            <p:nvPr/>
+          </p:nvPicPr>
+          <p:blipFill>
+            <a:blip r:embed="rId2">
+              <a:extLst>
+                <a:ext uri="{28A0092B-C50C-407E-A947-70E740481C1C}">
+                  <a14:useLocalDpi xmlns:a14="http://schemas.microsoft.com/office/drawing/2010/main" val="0"/>
+                </a:ext>
+              </a:extLst>
+            </a:blip>
+            <a:stretch>
+              <a:fillRect/>
+            </a:stretch>
+          </p:blipFill>
+          <p:spPr>
+            <a:xfrm>
+              <a:off x="478155" y="3053940"/>
+              <a:ext cx="2880000" cy="1800000"/>
+            </a:xfrm>
+            <a:prstGeom prst="rect">
+              <a:avLst/>
+            </a:prstGeom>
+          </p:spPr>
+        </p:pic>
+        <p:pic>
+          <p:nvPicPr>
+            <p:cNvPr id="7" name="图片 6">
+              <a:extLst>
+                <a:ext uri="{FF2B5EF4-FFF2-40B4-BE49-F238E27FC236}">
+                  <a16:creationId xmlns:a16="http://schemas.microsoft.com/office/drawing/2014/main" id="{170F49CF-CA51-3869-2318-A5B3E0B78182}"/>
+                </a:ext>
+              </a:extLst>
+            </p:cNvPr>
+            <p:cNvPicPr>
+              <a:picLocks noChangeAspect="1"/>
+            </p:cNvPicPr>
+            <p:nvPr/>
+          </p:nvPicPr>
+          <p:blipFill>
+            <a:blip r:embed="rId3">
+              <a:extLst>
+                <a:ext uri="{28A0092B-C50C-407E-A947-70E740481C1C}">
+                  <a14:useLocalDpi xmlns:a14="http://schemas.microsoft.com/office/drawing/2010/main" val="0"/>
+                </a:ext>
+              </a:extLst>
+            </a:blip>
+            <a:stretch>
+              <a:fillRect/>
+            </a:stretch>
+          </p:blipFill>
+          <p:spPr>
+            <a:xfrm>
+              <a:off x="3358155" y="3053940"/>
+              <a:ext cx="2880000" cy="1800000"/>
+            </a:xfrm>
+            <a:prstGeom prst="rect">
+              <a:avLst/>
+            </a:prstGeom>
+          </p:spPr>
+        </p:pic>
+        <p:pic>
+          <p:nvPicPr>
+            <p:cNvPr id="9" name="图片 8">
+              <a:extLst>
+                <a:ext uri="{FF2B5EF4-FFF2-40B4-BE49-F238E27FC236}">
+                  <a16:creationId xmlns:a16="http://schemas.microsoft.com/office/drawing/2014/main" id="{7C84ABDA-04FE-C173-D7A0-6722115E3E3D}"/>
+                </a:ext>
+              </a:extLst>
+            </p:cNvPr>
+            <p:cNvPicPr>
+              <a:picLocks noChangeAspect="1"/>
+            </p:cNvPicPr>
+            <p:nvPr/>
+          </p:nvPicPr>
+          <p:blipFill>
+            <a:blip r:embed="rId4">
+              <a:extLst>
+                <a:ext uri="{28A0092B-C50C-407E-A947-70E740481C1C}">
+                  <a14:useLocalDpi xmlns:a14="http://schemas.microsoft.com/office/drawing/2010/main" val="0"/>
+                </a:ext>
+              </a:extLst>
+            </a:blip>
+            <a:stretch>
+              <a:fillRect/>
+            </a:stretch>
+          </p:blipFill>
+          <p:spPr>
+            <a:xfrm>
+              <a:off x="3358155" y="4953000"/>
+              <a:ext cx="2880000" cy="1800000"/>
+            </a:xfrm>
+            <a:prstGeom prst="rect">
+              <a:avLst/>
+            </a:prstGeom>
+          </p:spPr>
+        </p:pic>
+        <p:pic>
+          <p:nvPicPr>
+            <p:cNvPr id="11" name="图片 10">
+              <a:extLst>
+                <a:ext uri="{FF2B5EF4-FFF2-40B4-BE49-F238E27FC236}">
+                  <a16:creationId xmlns:a16="http://schemas.microsoft.com/office/drawing/2014/main" id="{2A6BC685-A9F0-B670-8C57-A7C5F378E12C}"/>
+                </a:ext>
+              </a:extLst>
+            </p:cNvPr>
+            <p:cNvPicPr>
+              <a:picLocks noChangeAspect="1"/>
+            </p:cNvPicPr>
+            <p:nvPr/>
+          </p:nvPicPr>
+          <p:blipFill>
+            <a:blip r:embed="rId5">
+              <a:extLst>
+                <a:ext uri="{28A0092B-C50C-407E-A947-70E740481C1C}">
+                  <a14:useLocalDpi xmlns:a14="http://schemas.microsoft.com/office/drawing/2010/main" val="0"/>
+                </a:ext>
+              </a:extLst>
+            </a:blip>
+            <a:stretch>
+              <a:fillRect/>
+            </a:stretch>
+          </p:blipFill>
+          <p:spPr>
+            <a:xfrm>
+              <a:off x="478155" y="4953000"/>
+              <a:ext cx="2880000" cy="1800000"/>
+            </a:xfrm>
+            <a:prstGeom prst="rect">
+              <a:avLst/>
+            </a:prstGeom>
+          </p:spPr>
+        </p:pic>
+        <p:sp>
+          <p:nvSpPr>
+            <p:cNvPr id="12" name="文本框 11">
+              <a:extLst>
+                <a:ext uri="{FF2B5EF4-FFF2-40B4-BE49-F238E27FC236}">
+                  <a16:creationId xmlns:a16="http://schemas.microsoft.com/office/drawing/2014/main" id="{6D2A46A0-FE74-39F2-B30D-B856AF4F63DA}"/>
+                </a:ext>
+              </a:extLst>
+            </p:cNvPr>
+            <p:cNvSpPr txBox="1"/>
+            <p:nvPr/>
+          </p:nvSpPr>
+          <p:spPr>
+            <a:xfrm>
+              <a:off x="1171575" y="4764971"/>
+              <a:ext cx="2112645" cy="276999"/>
+            </a:xfrm>
+            <a:prstGeom prst="rect">
+              <a:avLst/>
+            </a:prstGeom>
+            <a:noFill/>
+          </p:spPr>
+          <p:txBody>
+            <a:bodyPr wrap="square" rtlCol="0">
+              <a:spAutoFit/>
+            </a:bodyPr>
+            <a:lstStyle/>
+            <a:p>
+              <a:r>
+                <a:rPr lang="zh-CN" altLang="en-US" sz="1200" dirty="0">
+                  <a:latin typeface="微软雅黑" panose="020B0503020204020204" pitchFamily="34" charset="-122"/>
+                  <a:ea typeface="微软雅黑" panose="020B0503020204020204" pitchFamily="34" charset="-122"/>
+                </a:rPr>
+                <a:t>工程效率最优方案</a:t>
+              </a:r>
+            </a:p>
+          </p:txBody>
+        </p:sp>
+        <p:sp>
+          <p:nvSpPr>
+            <p:cNvPr id="13" name="文本框 12">
+              <a:extLst>
+                <a:ext uri="{FF2B5EF4-FFF2-40B4-BE49-F238E27FC236}">
+                  <a16:creationId xmlns:a16="http://schemas.microsoft.com/office/drawing/2014/main" id="{701C042C-E4C7-48CD-EAD7-EE17D4C3BB50}"/>
+                </a:ext>
+              </a:extLst>
+            </p:cNvPr>
+            <p:cNvSpPr txBox="1"/>
+            <p:nvPr/>
+          </p:nvSpPr>
+          <p:spPr>
+            <a:xfrm>
+              <a:off x="4125510" y="4767442"/>
+              <a:ext cx="2112645" cy="276999"/>
+            </a:xfrm>
+            <a:prstGeom prst="rect">
+              <a:avLst/>
+            </a:prstGeom>
+            <a:noFill/>
+          </p:spPr>
+          <p:txBody>
+            <a:bodyPr wrap="square" rtlCol="0">
+              <a:spAutoFit/>
+            </a:bodyPr>
+            <a:lstStyle/>
+            <a:p>
+              <a:r>
+                <a:rPr lang="zh-CN" altLang="en-US" sz="1200" dirty="0">
+                  <a:latin typeface="微软雅黑" panose="020B0503020204020204" pitchFamily="34" charset="-122"/>
+                  <a:ea typeface="微软雅黑" panose="020B0503020204020204" pitchFamily="34" charset="-122"/>
+                </a:rPr>
+                <a:t>资源回收最优方案</a:t>
+              </a:r>
+            </a:p>
+          </p:txBody>
+        </p:sp>
+        <p:sp>
+          <p:nvSpPr>
+            <p:cNvPr id="14" name="文本框 13">
+              <a:extLst>
+                <a:ext uri="{FF2B5EF4-FFF2-40B4-BE49-F238E27FC236}">
+                  <a16:creationId xmlns:a16="http://schemas.microsoft.com/office/drawing/2014/main" id="{94C94127-C5C6-1DF8-1154-CF6F71ACAF10}"/>
+                </a:ext>
+              </a:extLst>
+            </p:cNvPr>
+            <p:cNvSpPr txBox="1"/>
+            <p:nvPr/>
+          </p:nvSpPr>
+          <p:spPr>
+            <a:xfrm>
+              <a:off x="1245510" y="6710197"/>
+              <a:ext cx="2112645" cy="276999"/>
+            </a:xfrm>
+            <a:prstGeom prst="rect">
+              <a:avLst/>
+            </a:prstGeom>
+            <a:noFill/>
+          </p:spPr>
+          <p:txBody>
+            <a:bodyPr wrap="square" rtlCol="0">
+              <a:spAutoFit/>
+            </a:bodyPr>
+            <a:lstStyle/>
+            <a:p>
+              <a:r>
+                <a:rPr lang="zh-CN" altLang="en-US" sz="1200" dirty="0">
+                  <a:latin typeface="微软雅黑" panose="020B0503020204020204" pitchFamily="34" charset="-122"/>
+                  <a:ea typeface="微软雅黑" panose="020B0503020204020204" pitchFamily="34" charset="-122"/>
+                </a:rPr>
+                <a:t>覆岩扰动优化方案</a:t>
+              </a:r>
+            </a:p>
+          </p:txBody>
+        </p:sp>
+        <p:sp>
+          <p:nvSpPr>
+            <p:cNvPr id="15" name="文本框 14">
+              <a:extLst>
+                <a:ext uri="{FF2B5EF4-FFF2-40B4-BE49-F238E27FC236}">
+                  <a16:creationId xmlns:a16="http://schemas.microsoft.com/office/drawing/2014/main" id="{6A9769D8-D88C-A7B2-5786-0BA9FE389720}"/>
+                </a:ext>
+              </a:extLst>
+            </p:cNvPr>
+            <p:cNvSpPr txBox="1"/>
+            <p:nvPr/>
+          </p:nvSpPr>
+          <p:spPr>
+            <a:xfrm>
+              <a:off x="2852505" y="6621227"/>
+              <a:ext cx="4005495" cy="461665"/>
+            </a:xfrm>
+            <a:prstGeom prst="rect">
+              <a:avLst/>
+            </a:prstGeom>
+            <a:noFill/>
+          </p:spPr>
+          <p:txBody>
+            <a:bodyPr wrap="square" rtlCol="0">
+              <a:spAutoFit/>
+            </a:bodyPr>
+            <a:lstStyle/>
+            <a:p>
+              <a:pPr algn="ctr"/>
+              <a:r>
+                <a:rPr lang="zh-CN" altLang="en-US" sz="1200" dirty="0">
+                  <a:latin typeface="Times New Roman" panose="02020603050405020304" pitchFamily="18" charset="0"/>
+                  <a:ea typeface="微软雅黑" panose="020B0503020204020204" pitchFamily="34" charset="-122"/>
+                  <a:cs typeface="Times New Roman" panose="02020603050405020304" pitchFamily="18" charset="0"/>
+                </a:rPr>
+                <a:t>自定义权重调节方案</a:t>
+              </a:r>
+              <a:br>
+                <a:rPr lang="en-US" altLang="zh-CN" sz="1200" dirty="0">
+                  <a:latin typeface="Times New Roman" panose="02020603050405020304" pitchFamily="18" charset="0"/>
+                  <a:ea typeface="微软雅黑" panose="020B0503020204020204" pitchFamily="34" charset="-122"/>
+                  <a:cs typeface="Times New Roman" panose="02020603050405020304" pitchFamily="18" charset="0"/>
+                </a:rPr>
+              </a:br>
+              <a:r>
+                <a:rPr lang="zh-CN" altLang="en-US" sz="1200" dirty="0">
+                  <a:latin typeface="Times New Roman" panose="02020603050405020304" pitchFamily="18" charset="0"/>
+                  <a:ea typeface="微软雅黑" panose="020B0503020204020204" pitchFamily="34" charset="-122"/>
+                  <a:cs typeface="Times New Roman" panose="02020603050405020304" pitchFamily="18" charset="0"/>
+                </a:rPr>
+                <a:t>（工程效率</a:t>
+              </a:r>
+              <a:r>
+                <a:rPr lang="en-US" altLang="zh-CN" sz="1200" dirty="0">
+                  <a:latin typeface="Times New Roman" panose="02020603050405020304" pitchFamily="18" charset="0"/>
+                  <a:ea typeface="微软雅黑" panose="020B0503020204020204" pitchFamily="34" charset="-122"/>
+                  <a:cs typeface="Times New Roman" panose="02020603050405020304" pitchFamily="18" charset="0"/>
+                </a:rPr>
+                <a:t>34 % +</a:t>
+              </a:r>
+              <a:r>
+                <a:rPr lang="zh-CN" altLang="en-US" sz="1200" dirty="0">
+                  <a:latin typeface="Times New Roman" panose="02020603050405020304" pitchFamily="18" charset="0"/>
+                  <a:ea typeface="微软雅黑" panose="020B0503020204020204" pitchFamily="34" charset="-122"/>
+                  <a:cs typeface="Times New Roman" panose="02020603050405020304" pitchFamily="18" charset="0"/>
+                </a:rPr>
+                <a:t>资源回收</a:t>
+              </a:r>
+              <a:r>
+                <a:rPr lang="en-US" altLang="zh-CN" sz="1200" dirty="0">
+                  <a:latin typeface="Times New Roman" panose="02020603050405020304" pitchFamily="18" charset="0"/>
+                  <a:ea typeface="微软雅黑" panose="020B0503020204020204" pitchFamily="34" charset="-122"/>
+                  <a:cs typeface="Times New Roman" panose="02020603050405020304" pitchFamily="18" charset="0"/>
+                </a:rPr>
+                <a:t>33 % +</a:t>
+              </a:r>
+              <a:r>
+                <a:rPr lang="zh-CN" altLang="en-US" sz="1200" dirty="0">
+                  <a:latin typeface="Times New Roman" panose="02020603050405020304" pitchFamily="18" charset="0"/>
+                  <a:ea typeface="微软雅黑" panose="020B0503020204020204" pitchFamily="34" charset="-122"/>
+                  <a:cs typeface="Times New Roman" panose="02020603050405020304" pitchFamily="18" charset="0"/>
+                </a:rPr>
+                <a:t>覆岩扰动</a:t>
+              </a:r>
+              <a:r>
+                <a:rPr lang="en-US" altLang="zh-CN" sz="1200" dirty="0">
+                  <a:latin typeface="Times New Roman" panose="02020603050405020304" pitchFamily="18" charset="0"/>
+                  <a:ea typeface="微软雅黑" panose="020B0503020204020204" pitchFamily="34" charset="-122"/>
+                  <a:cs typeface="Times New Roman" panose="02020603050405020304" pitchFamily="18" charset="0"/>
+                </a:rPr>
+                <a:t>33%</a:t>
+              </a:r>
+              <a:r>
+                <a:rPr lang="zh-CN" altLang="en-US" sz="1200" dirty="0">
+                  <a:latin typeface="Times New Roman" panose="02020603050405020304" pitchFamily="18" charset="0"/>
+                  <a:ea typeface="微软雅黑" panose="020B0503020204020204" pitchFamily="34" charset="-122"/>
+                  <a:cs typeface="Times New Roman" panose="02020603050405020304" pitchFamily="18" charset="0"/>
+                </a:rPr>
+                <a:t>）</a:t>
+              </a:r>
+            </a:p>
+          </p:txBody>
+        </p:sp>
+        <p:cxnSp>
+          <p:nvCxnSpPr>
+            <p:cNvPr id="17" name="直接箭头连接符 16">
+              <a:extLst>
+                <a:ext uri="{FF2B5EF4-FFF2-40B4-BE49-F238E27FC236}">
+                  <a16:creationId xmlns:a16="http://schemas.microsoft.com/office/drawing/2014/main" id="{1A02463F-11EB-13EB-0F0F-6DAD1E37B7B3}"/>
+                </a:ext>
+              </a:extLst>
+            </p:cNvPr>
+            <p:cNvCxnSpPr/>
+            <p:nvPr/>
+          </p:nvCxnSpPr>
+          <p:spPr>
+            <a:xfrm>
+              <a:off x="691515" y="3375660"/>
+              <a:ext cx="480060" cy="0"/>
+            </a:xfrm>
+            <a:prstGeom prst="straightConnector1">
+              <a:avLst/>
+            </a:prstGeom>
+            <a:ln>
+              <a:tailEnd type="triangle"/>
+            </a:ln>
+          </p:spPr>
+          <p:style>
+            <a:lnRef idx="2">
+              <a:schemeClr val="dk1"/>
+            </a:lnRef>
+            <a:fillRef idx="0">
+              <a:schemeClr val="dk1"/>
+            </a:fillRef>
+            <a:effectRef idx="1">
+              <a:schemeClr val="dk1"/>
+            </a:effectRef>
+            <a:fontRef idx="minor">
+              <a:schemeClr val="tx1"/>
+            </a:fontRef>
+          </p:style>
+        </p:cxnSp>
+        <p:sp>
+          <p:nvSpPr>
+            <p:cNvPr id="18" name="文本框 17">
+              <a:extLst>
+                <a:ext uri="{FF2B5EF4-FFF2-40B4-BE49-F238E27FC236}">
+                  <a16:creationId xmlns:a16="http://schemas.microsoft.com/office/drawing/2014/main" id="{EAB57DF2-18FD-58EB-BE3B-6353F809E3F2}"/>
+                </a:ext>
+              </a:extLst>
+            </p:cNvPr>
+            <p:cNvSpPr txBox="1"/>
+            <p:nvPr/>
+          </p:nvSpPr>
+          <p:spPr>
+            <a:xfrm>
+              <a:off x="115253" y="3237160"/>
+              <a:ext cx="745808" cy="276999"/>
+            </a:xfrm>
+            <a:prstGeom prst="rect">
+              <a:avLst/>
+            </a:prstGeom>
+            <a:noFill/>
+          </p:spPr>
+          <p:txBody>
+            <a:bodyPr wrap="square" rtlCol="0">
+              <a:spAutoFit/>
+            </a:bodyPr>
+            <a:lstStyle/>
+            <a:p>
+              <a:r>
+                <a:rPr lang="zh-CN" altLang="en-US" sz="1200" dirty="0">
+                  <a:latin typeface="微软雅黑" panose="020B0503020204020204" pitchFamily="34" charset="-122"/>
+                  <a:ea typeface="微软雅黑" panose="020B0503020204020204" pitchFamily="34" charset="-122"/>
+                </a:rPr>
+                <a:t>工作面</a:t>
+              </a:r>
+            </a:p>
+          </p:txBody>
+        </p:sp>
+        <p:cxnSp>
+          <p:nvCxnSpPr>
+            <p:cNvPr id="20" name="直接箭头连接符 19">
+              <a:extLst>
+                <a:ext uri="{FF2B5EF4-FFF2-40B4-BE49-F238E27FC236}">
+                  <a16:creationId xmlns:a16="http://schemas.microsoft.com/office/drawing/2014/main" id="{25DDF611-1A7C-A9E8-43E7-39A4532E9978}"/>
+                </a:ext>
+              </a:extLst>
+            </p:cNvPr>
+            <p:cNvCxnSpPr/>
+            <p:nvPr/>
+          </p:nvCxnSpPr>
+          <p:spPr>
+            <a:xfrm>
+              <a:off x="691515" y="3521779"/>
+              <a:ext cx="480060" cy="0"/>
+            </a:xfrm>
+            <a:prstGeom prst="straightConnector1">
+              <a:avLst/>
+            </a:prstGeom>
+            <a:ln>
+              <a:tailEnd type="triangle"/>
+            </a:ln>
+          </p:spPr>
+          <p:style>
+            <a:lnRef idx="2">
+              <a:schemeClr val="dk1"/>
+            </a:lnRef>
+            <a:fillRef idx="0">
+              <a:schemeClr val="dk1"/>
+            </a:fillRef>
+            <a:effectRef idx="1">
+              <a:schemeClr val="dk1"/>
+            </a:effectRef>
+            <a:fontRef idx="minor">
+              <a:schemeClr val="tx1"/>
+            </a:fontRef>
+          </p:style>
+        </p:cxnSp>
+        <p:sp>
+          <p:nvSpPr>
+            <p:cNvPr id="21" name="文本框 20">
+              <a:extLst>
+                <a:ext uri="{FF2B5EF4-FFF2-40B4-BE49-F238E27FC236}">
+                  <a16:creationId xmlns:a16="http://schemas.microsoft.com/office/drawing/2014/main" id="{24611777-3C73-765F-53A8-E2B51457DFA6}"/>
+                </a:ext>
+              </a:extLst>
+            </p:cNvPr>
+            <p:cNvSpPr txBox="1"/>
+            <p:nvPr/>
+          </p:nvSpPr>
+          <p:spPr>
+            <a:xfrm>
+              <a:off x="211931" y="3383279"/>
+              <a:ext cx="745808" cy="276999"/>
+            </a:xfrm>
+            <a:prstGeom prst="rect">
+              <a:avLst/>
+            </a:prstGeom>
+            <a:noFill/>
+          </p:spPr>
+          <p:txBody>
+            <a:bodyPr wrap="square" rtlCol="0">
+              <a:spAutoFit/>
+            </a:bodyPr>
+            <a:lstStyle/>
+            <a:p>
+              <a:r>
+                <a:rPr lang="zh-CN" altLang="en-US" sz="1200" dirty="0">
+                  <a:latin typeface="微软雅黑" panose="020B0503020204020204" pitchFamily="34" charset="-122"/>
+                  <a:ea typeface="微软雅黑" panose="020B0503020204020204" pitchFamily="34" charset="-122"/>
+                </a:rPr>
+                <a:t>煤柱</a:t>
+              </a:r>
+            </a:p>
+          </p:txBody>
+        </p:sp>
+      </p:grpSp>
+    </p:spTree>
+    <p:extLst>
+      <p:ext uri="{BB962C8B-B14F-4D97-AF65-F5344CB8AC3E}">
+        <p14:creationId xmlns:p14="http://schemas.microsoft.com/office/powerpoint/2010/main" val="225892509"/>
+      </p:ext>
+    </p:extLst>
+  </p:cSld>
+  <p:clrMapOvr>
+    <a:masterClrMapping/>
+  </p:clrMapOvr>
+</p:sld>
+</file>
+
 <file path=ppt/theme/theme1.xml><?xml version="1.0" encoding="utf-8"?>
 <a:theme xmlns:a="http://schemas.openxmlformats.org/drawingml/2006/main" name="Office 主题​​">
   <a:themeElements>

</xml_diff>

<commit_message>
Update training docs; add PNG image
Replace updated .docx and .pptx binaries in the 教育培训 directory and add a new PNG image used by the presentation. These are binary asset updates (no source code changes).
</commit_message>
<xml_diff>
--- a/煤科投稿/论文图片包/画图.pptx
+++ b/煤科投稿/论文图片包/画图.pptx
@@ -5,12 +5,14 @@
     <p:sldMasterId id="2147483660" r:id="rId1"/>
   </p:sldMasterIdLst>
   <p:notesMasterIdLst>
-    <p:notesMasterId r:id="rId5"/>
+    <p:notesMasterId r:id="rId7"/>
   </p:notesMasterIdLst>
   <p:sldIdLst>
     <p:sldId id="256" r:id="rId2"/>
     <p:sldId id="257" r:id="rId3"/>
     <p:sldId id="258" r:id="rId4"/>
+    <p:sldId id="259" r:id="rId5"/>
+    <p:sldId id="260" r:id="rId6"/>
   </p:sldIdLst>
   <p:sldSz cx="6858000" cy="9906000" type="A4"/>
   <p:notesSz cx="6858000" cy="9144000"/>
@@ -199,7 +201,7 @@
           <a:p>
             <a:fld id="{1C314F14-73D4-4D62-B57B-42E5203CBFCD}" type="datetimeFigureOut">
               <a:rPr lang="zh-CN" altLang="en-US" smtClean="0"/>
-              <a:t>2026/5/15</a:t>
+              <a:t>2026/5/21</a:t>
             </a:fld>
             <a:endParaRPr lang="zh-CN" altLang="en-US"/>
           </a:p>
@@ -686,7 +688,7 @@
           <a:p>
             <a:fld id="{7B6ED52D-95DF-48E9-888C-E126D2552AD7}" type="datetimeFigureOut">
               <a:rPr lang="zh-CN" altLang="en-US" smtClean="0"/>
-              <a:t>2026/5/15</a:t>
+              <a:t>2026/5/21</a:t>
             </a:fld>
             <a:endParaRPr lang="zh-CN" altLang="en-US"/>
           </a:p>
@@ -856,7 +858,7 @@
           <a:p>
             <a:fld id="{7B6ED52D-95DF-48E9-888C-E126D2552AD7}" type="datetimeFigureOut">
               <a:rPr lang="zh-CN" altLang="en-US" smtClean="0"/>
-              <a:t>2026/5/15</a:t>
+              <a:t>2026/5/21</a:t>
             </a:fld>
             <a:endParaRPr lang="zh-CN" altLang="en-US"/>
           </a:p>
@@ -1036,7 +1038,7 @@
           <a:p>
             <a:fld id="{7B6ED52D-95DF-48E9-888C-E126D2552AD7}" type="datetimeFigureOut">
               <a:rPr lang="zh-CN" altLang="en-US" smtClean="0"/>
-              <a:t>2026/5/15</a:t>
+              <a:t>2026/5/21</a:t>
             </a:fld>
             <a:endParaRPr lang="zh-CN" altLang="en-US"/>
           </a:p>
@@ -1206,7 +1208,7 @@
           <a:p>
             <a:fld id="{7B6ED52D-95DF-48E9-888C-E126D2552AD7}" type="datetimeFigureOut">
               <a:rPr lang="zh-CN" altLang="en-US" smtClean="0"/>
-              <a:t>2026/5/15</a:t>
+              <a:t>2026/5/21</a:t>
             </a:fld>
             <a:endParaRPr lang="zh-CN" altLang="en-US"/>
           </a:p>
@@ -1452,7 +1454,7 @@
           <a:p>
             <a:fld id="{7B6ED52D-95DF-48E9-888C-E126D2552AD7}" type="datetimeFigureOut">
               <a:rPr lang="zh-CN" altLang="en-US" smtClean="0"/>
-              <a:t>2026/5/15</a:t>
+              <a:t>2026/5/21</a:t>
             </a:fld>
             <a:endParaRPr lang="zh-CN" altLang="en-US"/>
           </a:p>
@@ -1684,7 +1686,7 @@
           <a:p>
             <a:fld id="{7B6ED52D-95DF-48E9-888C-E126D2552AD7}" type="datetimeFigureOut">
               <a:rPr lang="zh-CN" altLang="en-US" smtClean="0"/>
-              <a:t>2026/5/15</a:t>
+              <a:t>2026/5/21</a:t>
             </a:fld>
             <a:endParaRPr lang="zh-CN" altLang="en-US"/>
           </a:p>
@@ -2051,7 +2053,7 @@
           <a:p>
             <a:fld id="{7B6ED52D-95DF-48E9-888C-E126D2552AD7}" type="datetimeFigureOut">
               <a:rPr lang="zh-CN" altLang="en-US" smtClean="0"/>
-              <a:t>2026/5/15</a:t>
+              <a:t>2026/5/21</a:t>
             </a:fld>
             <a:endParaRPr lang="zh-CN" altLang="en-US"/>
           </a:p>
@@ -2169,7 +2171,7 @@
           <a:p>
             <a:fld id="{7B6ED52D-95DF-48E9-888C-E126D2552AD7}" type="datetimeFigureOut">
               <a:rPr lang="zh-CN" altLang="en-US" smtClean="0"/>
-              <a:t>2026/5/15</a:t>
+              <a:t>2026/5/21</a:t>
             </a:fld>
             <a:endParaRPr lang="zh-CN" altLang="en-US"/>
           </a:p>
@@ -2264,7 +2266,7 @@
           <a:p>
             <a:fld id="{7B6ED52D-95DF-48E9-888C-E126D2552AD7}" type="datetimeFigureOut">
               <a:rPr lang="zh-CN" altLang="en-US" smtClean="0"/>
-              <a:t>2026/5/15</a:t>
+              <a:t>2026/5/21</a:t>
             </a:fld>
             <a:endParaRPr lang="zh-CN" altLang="en-US"/>
           </a:p>
@@ -2541,7 +2543,7 @@
           <a:p>
             <a:fld id="{7B6ED52D-95DF-48E9-888C-E126D2552AD7}" type="datetimeFigureOut">
               <a:rPr lang="zh-CN" altLang="en-US" smtClean="0"/>
-              <a:t>2026/5/15</a:t>
+              <a:t>2026/5/21</a:t>
             </a:fld>
             <a:endParaRPr lang="zh-CN" altLang="en-US"/>
           </a:p>
@@ -2798,7 +2800,7 @@
           <a:p>
             <a:fld id="{7B6ED52D-95DF-48E9-888C-E126D2552AD7}" type="datetimeFigureOut">
               <a:rPr lang="zh-CN" altLang="en-US" smtClean="0"/>
-              <a:t>2026/5/15</a:t>
+              <a:t>2026/5/21</a:t>
             </a:fld>
             <a:endParaRPr lang="zh-CN" altLang="en-US"/>
           </a:p>
@@ -3011,7 +3013,7 @@
           <a:p>
             <a:fld id="{7B6ED52D-95DF-48E9-888C-E126D2552AD7}" type="datetimeFigureOut">
               <a:rPr lang="zh-CN" altLang="en-US" smtClean="0"/>
-              <a:t>2026/5/15</a:t>
+              <a:t>2026/5/21</a:t>
             </a:fld>
             <a:endParaRPr lang="zh-CN" altLang="en-US"/>
           </a:p>
@@ -4899,6 +4901,229 @@
 </p:sld>
 </file>
 
+<file path=ppt/slides/slide4.xml><?xml version="1.0" encoding="utf-8"?>
+<p:sld xmlns:a="http://schemas.openxmlformats.org/drawingml/2006/main" xmlns:r="http://schemas.openxmlformats.org/officeDocument/2006/relationships" xmlns:p="http://schemas.openxmlformats.org/presentationml/2006/main">
+  <p:cSld>
+    <p:spTree>
+      <p:nvGrpSpPr>
+        <p:cNvPr id="1" name=""/>
+        <p:cNvGrpSpPr/>
+        <p:nvPr/>
+      </p:nvGrpSpPr>
+      <p:grpSpPr>
+        <a:xfrm>
+          <a:off x="0" y="0"/>
+          <a:ext cx="0" cy="0"/>
+          <a:chOff x="0" y="0"/>
+          <a:chExt cx="0" cy="0"/>
+        </a:xfrm>
+      </p:grpSpPr>
+      <p:grpSp>
+        <p:nvGrpSpPr>
+          <p:cNvPr id="6" name="组合 5">
+            <a:extLst>
+              <a:ext uri="{FF2B5EF4-FFF2-40B4-BE49-F238E27FC236}">
+                <a16:creationId xmlns:a16="http://schemas.microsoft.com/office/drawing/2014/main" id="{B2D3D54E-6592-15EF-1CB0-958B016E914F}"/>
+              </a:ext>
+            </a:extLst>
+          </p:cNvPr>
+          <p:cNvGrpSpPr/>
+          <p:nvPr/>
+        </p:nvGrpSpPr>
+        <p:grpSpPr>
+          <a:xfrm>
+            <a:off x="0" y="1514242"/>
+            <a:ext cx="6858000" cy="6601913"/>
+            <a:chOff x="0" y="256942"/>
+            <a:chExt cx="6858000" cy="6601913"/>
+          </a:xfrm>
+        </p:grpSpPr>
+        <p:pic>
+          <p:nvPicPr>
+            <p:cNvPr id="4" name="图片 3">
+              <a:extLst>
+                <a:ext uri="{FF2B5EF4-FFF2-40B4-BE49-F238E27FC236}">
+                  <a16:creationId xmlns:a16="http://schemas.microsoft.com/office/drawing/2014/main" id="{DBC091DA-4CD8-FDD7-01CC-94B978801BFC}"/>
+                </a:ext>
+              </a:extLst>
+            </p:cNvPr>
+            <p:cNvPicPr>
+              <a:picLocks noChangeAspect="1"/>
+            </p:cNvPicPr>
+            <p:nvPr/>
+          </p:nvPicPr>
+          <p:blipFill>
+            <a:blip r:embed="rId2"/>
+            <a:stretch>
+              <a:fillRect/>
+            </a:stretch>
+          </p:blipFill>
+          <p:spPr>
+            <a:xfrm>
+              <a:off x="0" y="256942"/>
+              <a:ext cx="6858000" cy="3905715"/>
+            </a:xfrm>
+            <a:prstGeom prst="rect">
+              <a:avLst/>
+            </a:prstGeom>
+          </p:spPr>
+        </p:pic>
+        <p:pic>
+          <p:nvPicPr>
+            <p:cNvPr id="5" name="图片 4">
+              <a:extLst>
+                <a:ext uri="{FF2B5EF4-FFF2-40B4-BE49-F238E27FC236}">
+                  <a16:creationId xmlns:a16="http://schemas.microsoft.com/office/drawing/2014/main" id="{2E99F331-34BE-B6DF-9140-FF38739254D6}"/>
+                </a:ext>
+              </a:extLst>
+            </p:cNvPr>
+            <p:cNvPicPr>
+              <a:picLocks noChangeAspect="1"/>
+            </p:cNvPicPr>
+            <p:nvPr/>
+          </p:nvPicPr>
+          <p:blipFill>
+            <a:blip r:embed="rId3"/>
+            <a:stretch>
+              <a:fillRect/>
+            </a:stretch>
+          </p:blipFill>
+          <p:spPr>
+            <a:xfrm>
+              <a:off x="0" y="4162657"/>
+              <a:ext cx="6858000" cy="2696198"/>
+            </a:xfrm>
+            <a:prstGeom prst="rect">
+              <a:avLst/>
+            </a:prstGeom>
+          </p:spPr>
+        </p:pic>
+      </p:grpSp>
+    </p:spTree>
+    <p:extLst>
+      <p:ext uri="{BB962C8B-B14F-4D97-AF65-F5344CB8AC3E}">
+        <p14:creationId xmlns:p14="http://schemas.microsoft.com/office/powerpoint/2010/main" val="1758556565"/>
+      </p:ext>
+    </p:extLst>
+  </p:cSld>
+  <p:clrMapOvr>
+    <a:masterClrMapping/>
+  </p:clrMapOvr>
+</p:sld>
+</file>
+
+<file path=ppt/slides/slide5.xml><?xml version="1.0" encoding="utf-8"?>
+<p:sld xmlns:a="http://schemas.openxmlformats.org/drawingml/2006/main" xmlns:r="http://schemas.openxmlformats.org/officeDocument/2006/relationships" xmlns:p="http://schemas.openxmlformats.org/presentationml/2006/main">
+  <p:cSld>
+    <p:spTree>
+      <p:nvGrpSpPr>
+        <p:cNvPr id="1" name=""/>
+        <p:cNvGrpSpPr/>
+        <p:nvPr/>
+      </p:nvGrpSpPr>
+      <p:grpSpPr>
+        <a:xfrm>
+          <a:off x="0" y="0"/>
+          <a:ext cx="0" cy="0"/>
+          <a:chOff x="0" y="0"/>
+          <a:chExt cx="0" cy="0"/>
+        </a:xfrm>
+      </p:grpSpPr>
+      <p:grpSp>
+        <p:nvGrpSpPr>
+          <p:cNvPr id="6" name="组合 5">
+            <a:extLst>
+              <a:ext uri="{FF2B5EF4-FFF2-40B4-BE49-F238E27FC236}">
+                <a16:creationId xmlns:a16="http://schemas.microsoft.com/office/drawing/2014/main" id="{D760B1B6-E2EE-6A24-D1C1-C8CF861C45D6}"/>
+              </a:ext>
+            </a:extLst>
+          </p:cNvPr>
+          <p:cNvGrpSpPr/>
+          <p:nvPr/>
+        </p:nvGrpSpPr>
+        <p:grpSpPr>
+          <a:xfrm>
+            <a:off x="0" y="984757"/>
+            <a:ext cx="6858000" cy="7620874"/>
+            <a:chOff x="0" y="984757"/>
+            <a:chExt cx="6858000" cy="7620874"/>
+          </a:xfrm>
+        </p:grpSpPr>
+        <p:pic>
+          <p:nvPicPr>
+            <p:cNvPr id="4" name="图片 3">
+              <a:extLst>
+                <a:ext uri="{FF2B5EF4-FFF2-40B4-BE49-F238E27FC236}">
+                  <a16:creationId xmlns:a16="http://schemas.microsoft.com/office/drawing/2014/main" id="{3D05132A-6C83-9F49-B497-11D96D68BFA6}"/>
+                </a:ext>
+              </a:extLst>
+            </p:cNvPr>
+            <p:cNvPicPr>
+              <a:picLocks noChangeAspect="1"/>
+            </p:cNvPicPr>
+            <p:nvPr/>
+          </p:nvPicPr>
+          <p:blipFill>
+            <a:blip r:embed="rId2"/>
+            <a:srcRect l="1600"/>
+            <a:stretch>
+              <a:fillRect/>
+            </a:stretch>
+          </p:blipFill>
+          <p:spPr>
+            <a:xfrm>
+              <a:off x="79248" y="984757"/>
+              <a:ext cx="6778752" cy="4145536"/>
+            </a:xfrm>
+            <a:prstGeom prst="rect">
+              <a:avLst/>
+            </a:prstGeom>
+          </p:spPr>
+        </p:pic>
+        <p:pic>
+          <p:nvPicPr>
+            <p:cNvPr id="5" name="图片 4">
+              <a:extLst>
+                <a:ext uri="{FF2B5EF4-FFF2-40B4-BE49-F238E27FC236}">
+                  <a16:creationId xmlns:a16="http://schemas.microsoft.com/office/drawing/2014/main" id="{499D48F8-4DAF-CC00-AC7D-2FC31D85C831}"/>
+                </a:ext>
+              </a:extLst>
+            </p:cNvPr>
+            <p:cNvPicPr>
+              <a:picLocks noChangeAspect="1"/>
+            </p:cNvPicPr>
+            <p:nvPr/>
+          </p:nvPicPr>
+          <p:blipFill>
+            <a:blip r:embed="rId3"/>
+            <a:stretch>
+              <a:fillRect/>
+            </a:stretch>
+          </p:blipFill>
+          <p:spPr>
+            <a:xfrm>
+              <a:off x="0" y="5130293"/>
+              <a:ext cx="6858000" cy="3475338"/>
+            </a:xfrm>
+            <a:prstGeom prst="rect">
+              <a:avLst/>
+            </a:prstGeom>
+          </p:spPr>
+        </p:pic>
+      </p:grpSp>
+    </p:spTree>
+    <p:extLst>
+      <p:ext uri="{BB962C8B-B14F-4D97-AF65-F5344CB8AC3E}">
+        <p14:creationId xmlns:p14="http://schemas.microsoft.com/office/powerpoint/2010/main" val="638220007"/>
+      </p:ext>
+    </p:extLst>
+  </p:cSld>
+  <p:clrMapOvr>
+    <a:masterClrMapping/>
+  </p:clrMapOvr>
+</p:sld>
+</file>
+
 <file path=ppt/theme/theme1.xml><?xml version="1.0" encoding="utf-8"?>
 <a:theme xmlns:a="http://schemas.openxmlformats.org/drawingml/2006/main" name="Office 主题​​">
   <a:themeElements>

</xml_diff>